<commit_message>
Clarify two-engine roles in conversion deck
Both engines read each equation: Marker reads the whole page (layout,
tables, and equations) and MinerU re-reads the equations as an
independent second opinion. Reword the pipeline "Decide" step and the
decision ladder to talk about the two equation readings agreeing, so the
agreement check is consistent with how the engines are described.
</commit_message>
<xml_diff>
--- a/docs/CEM_AI_Conversion.pptx
+++ b/docs/CEM_AI_Conversion.pptx
@@ -12845,7 +12845,7 @@
                 </a:solidFill>
                 <a:latin typeface="Segoe UI"/>
               </a:rPr>
-              <a:t>Two separate engines read each page: Marker for layout and tables, MinerU for the equations.</a:t>
+              <a:t>Marker reads the whole page (layout, tables, and equations). MinerU reads the equations again as an independent second opinion.</a:t>
             </a:r>
           </a:p>
         </p:txBody>
@@ -13385,7 +13385,7 @@
                 </a:solidFill>
                 <a:latin typeface="Segoe UI"/>
               </a:rPr>
-              <a:t>If both engines agree and pass, accept. Otherwise take a single passing result, or move to self-correction.</a:t>
+              <a:t>For each equation, if the two readings agree and pass the checks, accept. Otherwise take a single passing reading, or self-correct.</a:t>
             </a:r>
           </a:p>
         </p:txBody>
@@ -15989,7 +15989,7 @@
                 </a:solidFill>
                 <a:latin typeface="Segoe UI"/>
               </a:rPr>
-              <a:t>Both engines agree and pass</a:t>
+              <a:t>Both engine readings agree</a:t>
             </a:r>
           </a:p>
         </p:txBody>
@@ -16214,7 +16214,7 @@
                 </a:solidFill>
                 <a:latin typeface="Segoe UI"/>
               </a:rPr>
-              <a:t>One result passes the checks</a:t>
+              <a:t>One reading passes the checks</a:t>
             </a:r>
           </a:p>
         </p:txBody>

</xml_diff>